<commit_message>
Rebuild Data Co-Pilot slide from July 15 usage report
Replace screenshot-template metrics with real PDF numbers: 26,082
queries, 4,583 users, 718 latest WAU, 2,592 June MAU, and updated
WAU trend / displacement annotations.

Co-authored-by: maiagordon-commits <maiagordon-commits@users.noreply.github.com>
</commit_message>
<xml_diff>
--- a/Data_Copilot_Usage_Summary.pptx
+++ b/Data_Copilot_Usage_Summary.pptx
@@ -136,43 +136,43 @@
               <c:strCache>
                 <c:ptCount val="13"/>
                 <c:pt idx="0">
-                  <c:v>1</c:v>
+                  <c:v>Apr 15</c:v>
                 </c:pt>
                 <c:pt idx="1">
-                  <c:v>2</c:v>
+                  <c:v>Apr 22</c:v>
                 </c:pt>
                 <c:pt idx="2">
-                  <c:v>3</c:v>
+                  <c:v>Apr 29</c:v>
                 </c:pt>
                 <c:pt idx="3">
-                  <c:v>4</c:v>
+                  <c:v>May 6</c:v>
                 </c:pt>
                 <c:pt idx="4">
-                  <c:v>5</c:v>
+                  <c:v>May 13</c:v>
                 </c:pt>
                 <c:pt idx="5">
-                  <c:v>6</c:v>
+                  <c:v>May 20</c:v>
                 </c:pt>
                 <c:pt idx="6">
-                  <c:v>7</c:v>
+                  <c:v>May 27</c:v>
                 </c:pt>
                 <c:pt idx="7">
-                  <c:v>8</c:v>
+                  <c:v>Jun 3</c:v>
                 </c:pt>
                 <c:pt idx="8">
-                  <c:v>9</c:v>
+                  <c:v>Jun 10</c:v>
                 </c:pt>
                 <c:pt idx="9">
-                  <c:v>10</c:v>
+                  <c:v>Jun 17</c:v>
                 </c:pt>
                 <c:pt idx="10">
-                  <c:v>11</c:v>
+                  <c:v>Jun 24</c:v>
                 </c:pt>
                 <c:pt idx="11">
-                  <c:v>12</c:v>
+                  <c:v>Jul 1</c:v>
                 </c:pt>
                 <c:pt idx="12">
-                  <c:v>13</c:v>
+                  <c:v>Jul 8</c:v>
                 </c:pt>
               </c:strCache>
             </c:strRef>
@@ -184,43 +184,43 @@
                 <c:formatCode>General</c:formatCode>
                 <c:ptCount val="13"/>
                 <c:pt idx="0">
-                  <c:v>48</c:v>
+                  <c:v>105</c:v>
                 </c:pt>
                 <c:pt idx="1">
-                  <c:v>55</c:v>
+                  <c:v>112</c:v>
                 </c:pt>
                 <c:pt idx="2">
-                  <c:v>62</c:v>
+                  <c:v>120</c:v>
                 </c:pt>
                 <c:pt idx="3">
-                  <c:v>70</c:v>
+                  <c:v>135</c:v>
                 </c:pt>
                 <c:pt idx="4">
-                  <c:v>74</c:v>
+                  <c:v>610</c:v>
                 </c:pt>
                 <c:pt idx="5">
-                  <c:v>88</c:v>
+                  <c:v>945</c:v>
                 </c:pt>
                 <c:pt idx="6">
-                  <c:v>796</c:v>
+                  <c:v>820</c:v>
                 </c:pt>
                 <c:pt idx="7">
-                  <c:v>812</c:v>
+                  <c:v>760</c:v>
                 </c:pt>
                 <c:pt idx="8">
-                  <c:v>745</c:v>
+                  <c:v>710</c:v>
                 </c:pt>
                 <c:pt idx="9">
-                  <c:v>868</c:v>
+                  <c:v>680</c:v>
                 </c:pt>
                 <c:pt idx="10">
-                  <c:v>885</c:v>
+                  <c:v>627</c:v>
                 </c:pt>
                 <c:pt idx="11">
-                  <c:v>778</c:v>
+                  <c:v>705</c:v>
                 </c:pt>
                 <c:pt idx="12">
-                  <c:v>486</c:v>
+                  <c:v>718</c:v>
                 </c:pt>
               </c:numCache>
             </c:numRef>
@@ -235,7 +235,7 @@
           </c:spPr>
           <c:marker>
             <c:symbol val="circle"/>
-            <c:size val="7"/>
+            <c:size val="6"/>
             <c:spPr>
               <a:solidFill>
                 <a:srgbClr val="0D9B8A"/>
@@ -275,7 +275,7 @@
           <a:lstStyle/>
           <a:p>
             <a:pPr>
-              <a:defRPr sz="900">
+              <a:defRPr sz="700">
                 <a:solidFill>
                   <a:srgbClr val="64748B"/>
                 </a:solidFill>
@@ -3355,8 +3355,8 @@
         </p:nvSpPr>
         <p:spPr>
           <a:xfrm>
-            <a:off x="411480" y="256032"/>
-            <a:ext cx="5486400" cy="457200"/>
+            <a:off x="411480" y="201168"/>
+            <a:ext cx="6400800" cy="411480"/>
           </a:xfrm>
           <a:prstGeom prst="rect">
             <a:avLst/>
@@ -3364,7 +3364,9 @@
           <a:noFill/>
         </p:spPr>
         <p:txBody>
-          <a:bodyPr wrap="square" anchor="t"/>
+          <a:bodyPr wrap="square">
+            <a:spAutoFit/>
+          </a:bodyPr>
           <a:lstStyle/>
           <a:p>
             <a:pPr algn="l"/>
@@ -3388,8 +3390,8 @@
         </p:nvSpPr>
         <p:spPr>
           <a:xfrm>
-            <a:off x="429768" y="658368"/>
-            <a:ext cx="7315200" cy="256032"/>
+            <a:off x="429768" y="585216"/>
+            <a:ext cx="8686800" cy="256032"/>
           </a:xfrm>
           <a:prstGeom prst="rect">
             <a:avLst/>
@@ -3397,7 +3399,9 @@
           <a:noFill/>
         </p:spPr>
         <p:txBody>
-          <a:bodyPr wrap="square" anchor="t"/>
+          <a:bodyPr wrap="square">
+            <a:spAutoFit/>
+          </a:bodyPr>
           <a:lstStyle/>
           <a:p>
             <a:pPr algn="l"/>
@@ -3408,7 +3412,7 @@
                 </a:solidFill>
                 <a:latin typeface="Calibri"/>
               </a:rPr>
-              <a:t>Usage summary · Q2 2026 · Source: Data Copilot Usage Report 2026-07-15</a:t>
+              <a:t>Usage summary · 3mo through Jul 15, 2026 · Coralogix + Datadog RUM · Source: Usage Report 2026-07-15</a:t>
             </a:r>
           </a:p>
         </p:txBody>
@@ -3421,8 +3425,8 @@
         </p:nvSpPr>
         <p:spPr>
           <a:xfrm>
-            <a:off x="411480" y="1051560"/>
-            <a:ext cx="2651760" cy="1051560"/>
+            <a:off x="411480" y="960120"/>
+            <a:ext cx="2651760" cy="1005840"/>
           </a:xfrm>
           <a:prstGeom prst="roundRect">
             <a:avLst>
@@ -3475,8 +3479,8 @@
         </p:nvSpPr>
         <p:spPr>
           <a:xfrm>
-            <a:off x="557784" y="1216152"/>
-            <a:ext cx="2395728" cy="502920"/>
+            <a:off x="521208" y="1106424"/>
+            <a:ext cx="2432304" cy="502920"/>
           </a:xfrm>
           <a:prstGeom prst="rect">
             <a:avLst/>
@@ -3484,7 +3488,9 @@
           <a:noFill/>
         </p:spPr>
         <p:txBody>
-          <a:bodyPr wrap="square" anchor="t"/>
+          <a:bodyPr wrap="square">
+            <a:spAutoFit/>
+          </a:bodyPr>
           <a:lstStyle/>
           <a:p>
             <a:pPr algn="ctr"/>
@@ -3495,7 +3501,7 @@
                 </a:solidFill>
                 <a:latin typeface="Calibri"/>
               </a:rPr>
-              <a:t>21,410</a:t>
+              <a:t>26,082</a:t>
             </a:r>
           </a:p>
         </p:txBody>
@@ -3508,8 +3514,8 @@
         </p:nvSpPr>
         <p:spPr>
           <a:xfrm>
-            <a:off x="521208" y="1709928"/>
-            <a:ext cx="2432304" cy="320040"/>
+            <a:off x="502920" y="1600200"/>
+            <a:ext cx="2468880" cy="347472"/>
           </a:xfrm>
           <a:prstGeom prst="rect">
             <a:avLst/>
@@ -3517,7 +3523,9 @@
           <a:noFill/>
         </p:spPr>
         <p:txBody>
-          <a:bodyPr wrap="square" anchor="t"/>
+          <a:bodyPr wrap="square">
+            <a:spAutoFit/>
+          </a:bodyPr>
           <a:lstStyle/>
           <a:p>
             <a:pPr algn="ctr"/>
@@ -3528,7 +3536,7 @@
                 </a:solidFill>
                 <a:latin typeface="Calibri"/>
               </a:rPr>
-              <a:t>Q2 Total Queries</a:t>
+              <a:t>Queries (3mo)</a:t>
             </a:r>
           </a:p>
         </p:txBody>
@@ -3541,8 +3549,8 @@
         </p:nvSpPr>
         <p:spPr>
           <a:xfrm>
-            <a:off x="3264408" y="1051560"/>
-            <a:ext cx="2651760" cy="1051560"/>
+            <a:off x="3264408" y="960120"/>
+            <a:ext cx="2651760" cy="1005840"/>
           </a:xfrm>
           <a:prstGeom prst="roundRect">
             <a:avLst>
@@ -3595,8 +3603,8 @@
         </p:nvSpPr>
         <p:spPr>
           <a:xfrm>
-            <a:off x="3410712" y="1216152"/>
-            <a:ext cx="2395728" cy="502920"/>
+            <a:off x="3374136" y="1106424"/>
+            <a:ext cx="2432304" cy="502920"/>
           </a:xfrm>
           <a:prstGeom prst="rect">
             <a:avLst/>
@@ -3604,7 +3612,9 @@
           <a:noFill/>
         </p:spPr>
         <p:txBody>
-          <a:bodyPr wrap="square" anchor="t"/>
+          <a:bodyPr wrap="square">
+            <a:spAutoFit/>
+          </a:bodyPr>
           <a:lstStyle/>
           <a:p>
             <a:pPr algn="ctr"/>
@@ -3615,7 +3625,7 @@
                 </a:solidFill>
                 <a:latin typeface="Calibri"/>
               </a:rPr>
-              <a:t>3,876</a:t>
+              <a:t>4,583</a:t>
             </a:r>
           </a:p>
         </p:txBody>
@@ -3628,8 +3638,8 @@
         </p:nvSpPr>
         <p:spPr>
           <a:xfrm>
-            <a:off x="3374136" y="1709928"/>
-            <a:ext cx="2432304" cy="320040"/>
+            <a:off x="3355848" y="1600200"/>
+            <a:ext cx="2468880" cy="347472"/>
           </a:xfrm>
           <a:prstGeom prst="rect">
             <a:avLst/>
@@ -3637,7 +3647,9 @@
           <a:noFill/>
         </p:spPr>
         <p:txBody>
-          <a:bodyPr wrap="square" anchor="t"/>
+          <a:bodyPr wrap="square">
+            <a:spAutoFit/>
+          </a:bodyPr>
           <a:lstStyle/>
           <a:p>
             <a:pPr algn="ctr"/>
@@ -3648,7 +3660,7 @@
                 </a:solidFill>
                 <a:latin typeface="Calibri"/>
               </a:rPr>
-              <a:t>Q2 Unique Users</a:t>
+              <a:t>Unique users</a:t>
             </a:r>
           </a:p>
         </p:txBody>
@@ -3661,8 +3673,8 @@
         </p:nvSpPr>
         <p:spPr>
           <a:xfrm>
-            <a:off x="6117336" y="1051560"/>
-            <a:ext cx="2651760" cy="1051560"/>
+            <a:off x="6117336" y="960120"/>
+            <a:ext cx="2651760" cy="1005840"/>
           </a:xfrm>
           <a:prstGeom prst="roundRect">
             <a:avLst>
@@ -3715,8 +3727,8 @@
         </p:nvSpPr>
         <p:spPr>
           <a:xfrm>
-            <a:off x="6263640" y="1216152"/>
-            <a:ext cx="2395728" cy="502920"/>
+            <a:off x="6227064" y="1106424"/>
+            <a:ext cx="2432304" cy="502920"/>
           </a:xfrm>
           <a:prstGeom prst="rect">
             <a:avLst/>
@@ -3724,7 +3736,9 @@
           <a:noFill/>
         </p:spPr>
         <p:txBody>
-          <a:bodyPr wrap="square" anchor="t"/>
+          <a:bodyPr wrap="square">
+            <a:spAutoFit/>
+          </a:bodyPr>
           <a:lstStyle/>
           <a:p>
             <a:pPr algn="ctr"/>
@@ -3735,7 +3749,7 @@
                 </a:solidFill>
                 <a:latin typeface="Calibri"/>
               </a:rPr>
-              <a:t>885</a:t>
+              <a:t>718</a:t>
             </a:r>
           </a:p>
         </p:txBody>
@@ -3748,8 +3762,8 @@
         </p:nvSpPr>
         <p:spPr>
           <a:xfrm>
-            <a:off x="6227064" y="1709928"/>
-            <a:ext cx="2432304" cy="320040"/>
+            <a:off x="6208776" y="1600200"/>
+            <a:ext cx="2468880" cy="347472"/>
           </a:xfrm>
           <a:prstGeom prst="rect">
             <a:avLst/>
@@ -3757,7 +3771,9 @@
           <a:noFill/>
         </p:spPr>
         <p:txBody>
-          <a:bodyPr wrap="square" anchor="t"/>
+          <a:bodyPr wrap="square">
+            <a:spAutoFit/>
+          </a:bodyPr>
           <a:lstStyle/>
           <a:p>
             <a:pPr algn="ctr"/>
@@ -3768,7 +3784,7 @@
                 </a:solidFill>
                 <a:latin typeface="Calibri"/>
               </a:rPr>
-              <a:t>Peak WAU (Post-GA)</a:t>
+              <a:t>Latest WAU (Jul 8)</a:t>
             </a:r>
           </a:p>
         </p:txBody>
@@ -3781,8 +3797,8 @@
         </p:nvSpPr>
         <p:spPr>
           <a:xfrm>
-            <a:off x="8970264" y="1051560"/>
-            <a:ext cx="2651760" cy="1051560"/>
+            <a:off x="8970264" y="960120"/>
+            <a:ext cx="2651760" cy="1005840"/>
           </a:xfrm>
           <a:prstGeom prst="roundRect">
             <a:avLst>
@@ -3835,8 +3851,8 @@
         </p:nvSpPr>
         <p:spPr>
           <a:xfrm>
-            <a:off x="9116568" y="1216152"/>
-            <a:ext cx="2395728" cy="502920"/>
+            <a:off x="9079992" y="1106424"/>
+            <a:ext cx="2432304" cy="502920"/>
           </a:xfrm>
           <a:prstGeom prst="rect">
             <a:avLst/>
@@ -3844,7 +3860,9 @@
           <a:noFill/>
         </p:spPr>
         <p:txBody>
-          <a:bodyPr wrap="square" anchor="t"/>
+          <a:bodyPr wrap="square">
+            <a:spAutoFit/>
+          </a:bodyPr>
           <a:lstStyle/>
           <a:p>
             <a:pPr algn="ctr"/>
@@ -3855,7 +3873,7 @@
                 </a:solidFill>
                 <a:latin typeface="Calibri"/>
               </a:rPr>
-              <a:t>3,220</a:t>
+              <a:t>2,592</a:t>
             </a:r>
           </a:p>
         </p:txBody>
@@ -3868,8 +3886,8 @@
         </p:nvSpPr>
         <p:spPr>
           <a:xfrm>
-            <a:off x="9079992" y="1709928"/>
-            <a:ext cx="2432304" cy="320040"/>
+            <a:off x="9061704" y="1600200"/>
+            <a:ext cx="2468880" cy="347472"/>
           </a:xfrm>
           <a:prstGeom prst="rect">
             <a:avLst/>
@@ -3877,7 +3895,9 @@
           <a:noFill/>
         </p:spPr>
         <p:txBody>
-          <a:bodyPr wrap="square" anchor="t"/>
+          <a:bodyPr wrap="square">
+            <a:spAutoFit/>
+          </a:bodyPr>
           <a:lstStyle/>
           <a:p>
             <a:pPr algn="ctr"/>
@@ -3888,7 +3908,7 @@
                 </a:solidFill>
                 <a:latin typeface="Calibri"/>
               </a:rPr>
-              <a:t>Unique Accounts</a:t>
+              <a:t>June MAU</a:t>
             </a:r>
           </a:p>
         </p:txBody>
@@ -3901,8 +3921,8 @@
         </p:nvSpPr>
         <p:spPr>
           <a:xfrm>
-            <a:off x="411480" y="2331720"/>
-            <a:ext cx="7452360" cy="4114800"/>
+            <a:off x="411480" y="2194560"/>
+            <a:ext cx="7452360" cy="4251960"/>
           </a:xfrm>
           <a:prstGeom prst="roundRect">
             <a:avLst>
@@ -3955,8 +3975,8 @@
         </p:nvSpPr>
         <p:spPr>
           <a:xfrm>
-            <a:off x="667512" y="2496312"/>
-            <a:ext cx="4572000" cy="365760"/>
+            <a:off x="667512" y="2322576"/>
+            <a:ext cx="3657600" cy="320040"/>
           </a:xfrm>
           <a:prstGeom prst="rect">
             <a:avLst/>
@@ -3964,7 +3984,9 @@
           <a:noFill/>
         </p:spPr>
         <p:txBody>
-          <a:bodyPr wrap="square" anchor="t"/>
+          <a:bodyPr wrap="square">
+            <a:spAutoFit/>
+          </a:bodyPr>
           <a:lstStyle/>
           <a:p>
             <a:pPr algn="l"/>
@@ -3975,22 +3997,57 @@
                 </a:solidFill>
                 <a:latin typeface="Georgia"/>
               </a:rPr>
-              <a:t>Weekly Active Users</a:t>
+              <a:t>WAU trend</a:t>
+            </a:r>
+          </a:p>
+        </p:txBody>
+      </p:sp>
+      <p:sp>
+        <p:nvSpPr>
+          <p:cNvPr id="19" name="TextBox 18"/>
+          <p:cNvSpPr txBox="1"/>
+          <p:nvPr/>
+        </p:nvSpPr>
+        <p:spPr>
+          <a:xfrm>
+            <a:off x="667512" y="2615184"/>
+            <a:ext cx="6858000" cy="228600"/>
+          </a:xfrm>
+          <a:prstGeom prst="rect">
+            <a:avLst/>
+          </a:prstGeom>
+          <a:noFill/>
+        </p:spPr>
+        <p:txBody>
+          <a:bodyPr wrap="square">
+            <a:spAutoFit/>
+          </a:bodyPr>
+          <a:lstStyle/>
+          <a:p>
+            <a:pPr algn="l"/>
+            <a:r>
+              <a:rPr sz="900" b="0">
+                <a:solidFill>
+                  <a:srgbClr val="64748B"/>
+                </a:solidFill>
+                <a:latin typeface="Calibri"/>
+              </a:rPr>
+              <a:t>Coralogix chat_response · weekly buckets · Jul 15 partial day excluded</a:t>
             </a:r>
           </a:p>
         </p:txBody>
       </p:sp>
       <p:graphicFrame>
         <p:nvGraphicFramePr>
-          <p:cNvPr id="19" name="Chart 18"/>
+          <p:cNvPr id="20" name="Chart 19"/>
           <p:cNvGraphicFramePr>
             <a:graphicFrameLocks noGrp="1"/>
           </p:cNvGraphicFramePr>
           <p:nvPr/>
         </p:nvGraphicFramePr>
         <p:xfrm>
-          <a:off x="594360" y="2880360"/>
-          <a:ext cx="7132320" cy="3429000"/>
+          <a:off x="548640" y="2880360"/>
+          <a:ext cx="7178040" cy="3200400"/>
         </p:xfrm>
         <a:graphic>
           <a:graphicData uri="http://schemas.openxmlformats.org/drawingml/2006/chart">
@@ -4000,14 +4057,243 @@
       </p:graphicFrame>
       <p:sp>
         <p:nvSpPr>
-          <p:cNvPr id="20" name="Rounded Rectangle 19"/>
+          <p:cNvPr id="21" name="TextBox 20"/>
+          <p:cNvSpPr txBox="1"/>
+          <p:nvPr/>
+        </p:nvSpPr>
+        <p:spPr>
+          <a:xfrm>
+            <a:off x="667512" y="6099048"/>
+            <a:ext cx="6995160" cy="274320"/>
+          </a:xfrm>
+          <a:prstGeom prst="rect">
+            <a:avLst/>
+          </a:prstGeom>
+          <a:noFill/>
+        </p:spPr>
+        <p:txBody>
+          <a:bodyPr wrap="square">
+            <a:spAutoFit/>
+          </a:bodyPr>
+          <a:lstStyle/>
+          <a:p>
+            <a:pPr algn="l"/>
+            <a:r>
+              <a:rPr sz="1000" b="0">
+                <a:solidFill>
+                  <a:srgbClr val="334155"/>
+                </a:solidFill>
+                <a:latin typeface="Calibri"/>
+              </a:rPr>
+              <a:t>GA week May 13 → peak 945 (May 20) → June soft patch 627 → July ~700+</a:t>
+            </a:r>
+          </a:p>
+        </p:txBody>
+      </p:sp>
+      <p:sp>
+        <p:nvSpPr>
+          <p:cNvPr id="22" name="Rounded Rectangle 21"/>
           <p:cNvSpPr/>
           <p:nvPr/>
         </p:nvSpPr>
         <p:spPr>
           <a:xfrm>
-            <a:off x="8138160" y="2331720"/>
-            <a:ext cx="3611880" cy="1234440"/>
+            <a:off x="8138160" y="2194560"/>
+            <a:ext cx="3611880" cy="1280160"/>
+          </a:xfrm>
+          <a:prstGeom prst="roundRect">
+            <a:avLst>
+              <a:gd name="adj" fmla="val 8000"/>
+            </a:avLst>
+          </a:prstGeom>
+          <a:solidFill>
+            <a:srgbClr val="E6F7F4"/>
+          </a:solidFill>
+          <a:ln w="15875">
+            <a:solidFill>
+              <a:srgbClr val="0D9B8A"/>
+            </a:solidFill>
+          </a:ln>
+          <a:effectLst>
+            <a:outerShdw blurRad="50800" dist="38100" dir="2700000" algn="tl" rotWithShape="0">
+              <a:srgbClr val="1A2B4A">
+                <a:alpha val="12000"/>
+              </a:srgbClr>
+            </a:outerShdw>
+          </a:effectLst>
+        </p:spPr>
+        <p:style>
+          <a:lnRef idx="1">
+            <a:schemeClr val="accent1"/>
+          </a:lnRef>
+          <a:fillRef idx="3">
+            <a:schemeClr val="accent1"/>
+          </a:fillRef>
+          <a:effectRef idx="2">
+            <a:schemeClr val="accent1"/>
+          </a:effectRef>
+          <a:fontRef idx="minor">
+            <a:schemeClr val="lt1"/>
+          </a:fontRef>
+        </p:style>
+        <p:txBody>
+          <a:bodyPr rtlCol="0" anchor="ctr"/>
+          <a:lstStyle/>
+          <a:p>
+            <a:pPr algn="ctr"/>
+          </a:p>
+        </p:txBody>
+      </p:sp>
+      <p:sp>
+        <p:nvSpPr>
+          <p:cNvPr id="23" name="TextBox 22"/>
+          <p:cNvSpPr txBox="1"/>
+          <p:nvPr/>
+        </p:nvSpPr>
+        <p:spPr>
+          <a:xfrm>
+            <a:off x="8284464" y="2286000"/>
+            <a:ext cx="3355848" cy="256032"/>
+          </a:xfrm>
+          <a:prstGeom prst="rect">
+            <a:avLst/>
+          </a:prstGeom>
+          <a:noFill/>
+        </p:spPr>
+        <p:txBody>
+          <a:bodyPr wrap="square">
+            <a:spAutoFit/>
+          </a:bodyPr>
+          <a:lstStyle/>
+          <a:p>
+            <a:pPr algn="l"/>
+            <a:r>
+              <a:rPr sz="1100" b="1">
+                <a:solidFill>
+                  <a:srgbClr val="1A2B4A"/>
+                </a:solidFill>
+                <a:latin typeface="Calibri"/>
+              </a:rPr>
+              <a:t>GA → Peak (May 13–20)</a:t>
+            </a:r>
+          </a:p>
+        </p:txBody>
+      </p:sp>
+      <p:sp>
+        <p:nvSpPr>
+          <p:cNvPr id="24" name="TextBox 23"/>
+          <p:cNvSpPr txBox="1"/>
+          <p:nvPr/>
+        </p:nvSpPr>
+        <p:spPr>
+          <a:xfrm>
+            <a:off x="8284464" y="2523744"/>
+            <a:ext cx="960120" cy="347472"/>
+          </a:xfrm>
+          <a:prstGeom prst="rect">
+            <a:avLst/>
+          </a:prstGeom>
+          <a:noFill/>
+        </p:spPr>
+        <p:txBody>
+          <a:bodyPr wrap="square">
+            <a:spAutoFit/>
+          </a:bodyPr>
+          <a:lstStyle/>
+          <a:p>
+            <a:pPr algn="l"/>
+            <a:r>
+              <a:rPr sz="2200" b="1">
+                <a:solidFill>
+                  <a:srgbClr val="0D9B8A"/>
+                </a:solidFill>
+                <a:latin typeface="Calibri"/>
+              </a:rPr>
+              <a:t>945</a:t>
+            </a:r>
+          </a:p>
+        </p:txBody>
+      </p:sp>
+      <p:sp>
+        <p:nvSpPr>
+          <p:cNvPr id="25" name="TextBox 24"/>
+          <p:cNvSpPr txBox="1"/>
+          <p:nvPr/>
+        </p:nvSpPr>
+        <p:spPr>
+          <a:xfrm>
+            <a:off x="9235440" y="2633472"/>
+            <a:ext cx="2331720" cy="256032"/>
+          </a:xfrm>
+          <a:prstGeom prst="rect">
+            <a:avLst/>
+          </a:prstGeom>
+          <a:noFill/>
+        </p:spPr>
+        <p:txBody>
+          <a:bodyPr wrap="square">
+            <a:spAutoFit/>
+          </a:bodyPr>
+          <a:lstStyle/>
+          <a:p>
+            <a:pPr algn="l"/>
+            <a:r>
+              <a:rPr sz="1000" b="0">
+                <a:solidFill>
+                  <a:srgbClr val="64748B"/>
+                </a:solidFill>
+                <a:latin typeface="Calibri"/>
+              </a:rPr>
+              <a:t>peak WAU</a:t>
+            </a:r>
+          </a:p>
+        </p:txBody>
+      </p:sp>
+      <p:sp>
+        <p:nvSpPr>
+          <p:cNvPr id="26" name="TextBox 25"/>
+          <p:cNvSpPr txBox="1"/>
+          <p:nvPr/>
+        </p:nvSpPr>
+        <p:spPr>
+          <a:xfrm>
+            <a:off x="8284464" y="2944368"/>
+            <a:ext cx="3319272" cy="411480"/>
+          </a:xfrm>
+          <a:prstGeom prst="rect">
+            <a:avLst/>
+          </a:prstGeom>
+          <a:noFill/>
+        </p:spPr>
+        <p:txBody>
+          <a:bodyPr wrap="square">
+            <a:spAutoFit/>
+          </a:bodyPr>
+          <a:lstStyle/>
+          <a:p>
+            <a:pPr algn="l"/>
+            <a:r>
+              <a:rPr sz="1000" b="0">
+                <a:solidFill>
+                  <a:srgbClr val="334155"/>
+                </a:solidFill>
+                <a:latin typeface="Calibri"/>
+              </a:rPr>
+              <a:t>GA week May 13 · May peak 945 · SQL gen 69.5% · CSV of SQL 83.8%.</a:t>
+            </a:r>
+          </a:p>
+        </p:txBody>
+      </p:sp>
+      <p:sp>
+        <p:nvSpPr>
+          <p:cNvPr id="27" name="Rounded Rectangle 26"/>
+          <p:cNvSpPr/>
+          <p:nvPr/>
+        </p:nvSpPr>
+        <p:spPr>
+          <a:xfrm>
+            <a:off x="8138160" y="3584448"/>
+            <a:ext cx="3611880" cy="1280160"/>
           </a:xfrm>
           <a:prstGeom prst="roundRect">
             <a:avLst>
@@ -4054,13 +4340,13 @@
       </p:sp>
       <p:sp>
         <p:nvSpPr>
-          <p:cNvPr id="21" name="TextBox 20"/>
+          <p:cNvPr id="28" name="TextBox 27"/>
           <p:cNvSpPr txBox="1"/>
           <p:nvPr/>
         </p:nvSpPr>
         <p:spPr>
           <a:xfrm>
-            <a:off x="8284464" y="2423160"/>
+            <a:off x="8284464" y="3675888"/>
             <a:ext cx="3355848" cy="256032"/>
           </a:xfrm>
           <a:prstGeom prst="rect">
@@ -4069,7 +4355,9 @@
           <a:noFill/>
         </p:spPr>
         <p:txBody>
-          <a:bodyPr wrap="square" anchor="t"/>
+          <a:bodyPr wrap="square">
+            <a:spAutoFit/>
+          </a:bodyPr>
           <a:lstStyle/>
           <a:p>
             <a:pPr algn="l"/>
@@ -4080,21 +4368,21 @@
                 </a:solidFill>
                 <a:latin typeface="Calibri"/>
               </a:rPr>
-              <a:t>Pre-GA (Apr 1 – May 17)</a:t>
-            </a:r>
-          </a:p>
-        </p:txBody>
-      </p:sp>
-      <p:sp>
-        <p:nvSpPr>
-          <p:cNvPr id="22" name="TextBox 21"/>
+              <a:t>June soft patch → July</a:t>
+            </a:r>
+          </a:p>
+        </p:txBody>
+      </p:sp>
+      <p:sp>
+        <p:nvSpPr>
+          <p:cNvPr id="29" name="TextBox 28"/>
           <p:cNvSpPr txBox="1"/>
           <p:nvPr/>
         </p:nvSpPr>
         <p:spPr>
           <a:xfrm>
-            <a:off x="8284464" y="2660904"/>
-            <a:ext cx="822960" cy="347472"/>
+            <a:off x="8284464" y="3913632"/>
+            <a:ext cx="960120" cy="347472"/>
           </a:xfrm>
           <a:prstGeom prst="rect">
             <a:avLst/>
@@ -4102,7 +4390,9 @@
           <a:noFill/>
         </p:spPr>
         <p:txBody>
-          <a:bodyPr wrap="square" anchor="t"/>
+          <a:bodyPr wrap="square">
+            <a:spAutoFit/>
+          </a:bodyPr>
           <a:lstStyle/>
           <a:p>
             <a:pPr algn="l"/>
@@ -4113,21 +4403,21 @@
                 </a:solidFill>
                 <a:latin typeface="Calibri"/>
               </a:rPr>
-              <a:t>67</a:t>
-            </a:r>
-          </a:p>
-        </p:txBody>
-      </p:sp>
-      <p:sp>
-        <p:nvSpPr>
-          <p:cNvPr id="23" name="TextBox 22"/>
+              <a:t>718</a:t>
+            </a:r>
+          </a:p>
+        </p:txBody>
+      </p:sp>
+      <p:sp>
+        <p:nvSpPr>
+          <p:cNvPr id="30" name="TextBox 29"/>
           <p:cNvSpPr txBox="1"/>
           <p:nvPr/>
         </p:nvSpPr>
         <p:spPr>
           <a:xfrm>
-            <a:off x="9098280" y="2770632"/>
-            <a:ext cx="2468880" cy="256032"/>
+            <a:off x="9235440" y="4023360"/>
+            <a:ext cx="2331720" cy="256032"/>
           </a:xfrm>
           <a:prstGeom prst="rect">
             <a:avLst/>
@@ -4135,7 +4425,9 @@
           <a:noFill/>
         </p:spPr>
         <p:txBody>
-          <a:bodyPr wrap="square" anchor="t"/>
+          <a:bodyPr wrap="square">
+            <a:spAutoFit/>
+          </a:bodyPr>
           <a:lstStyle/>
           <a:p>
             <a:pPr algn="l"/>
@@ -4146,21 +4438,21 @@
                 </a:solidFill>
                 <a:latin typeface="Calibri"/>
               </a:rPr>
-              <a:t>avg WAU</a:t>
-            </a:r>
-          </a:p>
-        </p:txBody>
-      </p:sp>
-      <p:sp>
-        <p:nvSpPr>
-          <p:cNvPr id="24" name="TextBox 23"/>
+              <a:t>latest WAU</a:t>
+            </a:r>
+          </a:p>
+        </p:txBody>
+      </p:sp>
+      <p:sp>
+        <p:nvSpPr>
+          <p:cNvPr id="31" name="TextBox 30"/>
           <p:cNvSpPr txBox="1"/>
           <p:nvPr/>
         </p:nvSpPr>
         <p:spPr>
           <a:xfrm>
-            <a:off x="8284464" y="3081528"/>
-            <a:ext cx="3319272" cy="365760"/>
+            <a:off x="8284464" y="4334256"/>
+            <a:ext cx="3319272" cy="411480"/>
           </a:xfrm>
           <a:prstGeom prst="rect">
             <a:avLst/>
@@ -4168,7 +4460,9 @@
           <a:noFill/>
         </p:spPr>
         <p:txBody>
-          <a:bodyPr wrap="square" anchor="t"/>
+          <a:bodyPr wrap="square">
+            <a:spAutoFit/>
+          </a:bodyPr>
           <a:lstStyle/>
           <a:p>
             <a:pPr algn="l"/>
@@ -4179,207 +4473,21 @@
                 </a:solidFill>
                 <a:latin typeface="Calibri"/>
               </a:rPr>
-              <a:t>1,862 total queries · max 88 WAU in the final pre-GA week.</a:t>
-            </a:r>
-          </a:p>
-        </p:txBody>
-      </p:sp>
-      <p:sp>
-        <p:nvSpPr>
-          <p:cNvPr id="25" name="Rounded Rectangle 24"/>
+              <a:t>Soft patch 627 · July ~700+ · Steady run-rate; June MAU 2.6k.</a:t>
+            </a:r>
+          </a:p>
+        </p:txBody>
+      </p:sp>
+      <p:sp>
+        <p:nvSpPr>
+          <p:cNvPr id="32" name="Rounded Rectangle 31"/>
           <p:cNvSpPr/>
           <p:nvPr/>
         </p:nvSpPr>
         <p:spPr>
           <a:xfrm>
-            <a:off x="8138160" y="3703320"/>
-            <a:ext cx="3611880" cy="1234440"/>
-          </a:xfrm>
-          <a:prstGeom prst="roundRect">
-            <a:avLst>
-              <a:gd name="adj" fmla="val 8000"/>
-            </a:avLst>
-          </a:prstGeom>
-          <a:solidFill>
-            <a:srgbClr val="E6F7F4"/>
-          </a:solidFill>
-          <a:ln w="15875">
-            <a:solidFill>
-              <a:srgbClr val="0D9B8A"/>
-            </a:solidFill>
-          </a:ln>
-          <a:effectLst>
-            <a:outerShdw blurRad="50800" dist="38100" dir="2700000" algn="tl" rotWithShape="0">
-              <a:srgbClr val="1A2B4A">
-                <a:alpha val="12000"/>
-              </a:srgbClr>
-            </a:outerShdw>
-          </a:effectLst>
-        </p:spPr>
-        <p:style>
-          <a:lnRef idx="1">
-            <a:schemeClr val="accent1"/>
-          </a:lnRef>
-          <a:fillRef idx="3">
-            <a:schemeClr val="accent1"/>
-          </a:fillRef>
-          <a:effectRef idx="2">
-            <a:schemeClr val="accent1"/>
-          </a:effectRef>
-          <a:fontRef idx="minor">
-            <a:schemeClr val="lt1"/>
-          </a:fontRef>
-        </p:style>
-        <p:txBody>
-          <a:bodyPr rtlCol="0" anchor="ctr"/>
-          <a:lstStyle/>
-          <a:p>
-            <a:pPr algn="ctr"/>
-          </a:p>
-        </p:txBody>
-      </p:sp>
-      <p:sp>
-        <p:nvSpPr>
-          <p:cNvPr id="26" name="TextBox 25"/>
-          <p:cNvSpPr txBox="1"/>
-          <p:nvPr/>
-        </p:nvSpPr>
-        <p:spPr>
-          <a:xfrm>
-            <a:off x="8284464" y="3794760"/>
-            <a:ext cx="3355848" cy="256032"/>
-          </a:xfrm>
-          <a:prstGeom prst="rect">
-            <a:avLst/>
-          </a:prstGeom>
-          <a:noFill/>
-        </p:spPr>
-        <p:txBody>
-          <a:bodyPr wrap="square" anchor="t"/>
-          <a:lstStyle/>
-          <a:p>
-            <a:pPr algn="l"/>
-            <a:r>
-              <a:rPr sz="1100" b="1">
-                <a:solidFill>
-                  <a:srgbClr val="1A2B4A"/>
-                </a:solidFill>
-                <a:latin typeface="Calibri"/>
-              </a:rPr>
-              <a:t>GA Launch (May 18)</a:t>
-            </a:r>
-          </a:p>
-        </p:txBody>
-      </p:sp>
-      <p:sp>
-        <p:nvSpPr>
-          <p:cNvPr id="27" name="TextBox 26"/>
-          <p:cNvSpPr txBox="1"/>
-          <p:nvPr/>
-        </p:nvSpPr>
-        <p:spPr>
-          <a:xfrm>
-            <a:off x="8284464" y="4032504"/>
-            <a:ext cx="822960" cy="347472"/>
-          </a:xfrm>
-          <a:prstGeom prst="rect">
-            <a:avLst/>
-          </a:prstGeom>
-          <a:noFill/>
-        </p:spPr>
-        <p:txBody>
-          <a:bodyPr wrap="square" anchor="t"/>
-          <a:lstStyle/>
-          <a:p>
-            <a:pPr algn="l"/>
-            <a:r>
-              <a:rPr sz="2200" b="1">
-                <a:solidFill>
-                  <a:srgbClr val="0D9B8A"/>
-                </a:solidFill>
-                <a:latin typeface="Calibri"/>
-              </a:rPr>
-              <a:t>796</a:t>
-            </a:r>
-          </a:p>
-        </p:txBody>
-      </p:sp>
-      <p:sp>
-        <p:nvSpPr>
-          <p:cNvPr id="28" name="TextBox 27"/>
-          <p:cNvSpPr txBox="1"/>
-          <p:nvPr/>
-        </p:nvSpPr>
-        <p:spPr>
-          <a:xfrm>
-            <a:off x="9098280" y="4142232"/>
-            <a:ext cx="2468880" cy="256032"/>
-          </a:xfrm>
-          <a:prstGeom prst="rect">
-            <a:avLst/>
-          </a:prstGeom>
-          <a:noFill/>
-        </p:spPr>
-        <p:txBody>
-          <a:bodyPr wrap="square" anchor="t"/>
-          <a:lstStyle/>
-          <a:p>
-            <a:pPr algn="l"/>
-            <a:r>
-              <a:rPr sz="1000" b="0">
-                <a:solidFill>
-                  <a:srgbClr val="64748B"/>
-                </a:solidFill>
-                <a:latin typeface="Calibri"/>
-              </a:rPr>
-              <a:t>WAU (launch week)</a:t>
-            </a:r>
-          </a:p>
-        </p:txBody>
-      </p:sp>
-      <p:sp>
-        <p:nvSpPr>
-          <p:cNvPr id="29" name="TextBox 28"/>
-          <p:cNvSpPr txBox="1"/>
-          <p:nvPr/>
-        </p:nvSpPr>
-        <p:spPr>
-          <a:xfrm>
-            <a:off x="8284464" y="4453128"/>
-            <a:ext cx="3319272" cy="365760"/>
-          </a:xfrm>
-          <a:prstGeom prst="rect">
-            <a:avLst/>
-          </a:prstGeom>
-          <a:noFill/>
-        </p:spPr>
-        <p:txBody>
-          <a:bodyPr wrap="square" anchor="t"/>
-          <a:lstStyle/>
-          <a:p>
-            <a:pPr algn="l"/>
-            <a:r>
-              <a:rPr sz="1000" b="0">
-                <a:solidFill>
-                  <a:srgbClr val="334155"/>
-                </a:solidFill>
-                <a:latin typeface="Calibri"/>
-              </a:rPr>
-              <a:t>11x surge (88 → 796) · 5,176 queries in 7 days — a record.</a:t>
-            </a:r>
-          </a:p>
-        </p:txBody>
-      </p:sp>
-      <p:sp>
-        <p:nvSpPr>
-          <p:cNvPr id="30" name="Rounded Rectangle 29"/>
-          <p:cNvSpPr/>
-          <p:nvPr/>
-        </p:nvSpPr>
-        <p:spPr>
-          <a:xfrm>
-            <a:off x="8138160" y="5074920"/>
-            <a:ext cx="3611880" cy="1234440"/>
+            <a:off x="8138160" y="4974336"/>
+            <a:ext cx="3611880" cy="1280160"/>
           </a:xfrm>
           <a:prstGeom prst="roundRect">
             <a:avLst>
@@ -4426,13 +4534,13 @@
       </p:sp>
       <p:sp>
         <p:nvSpPr>
-          <p:cNvPr id="31" name="TextBox 30"/>
+          <p:cNvPr id="33" name="TextBox 32"/>
           <p:cNvSpPr txBox="1"/>
           <p:nvPr/>
         </p:nvSpPr>
         <p:spPr>
           <a:xfrm>
-            <a:off x="8284464" y="5166360"/>
+            <a:off x="8284464" y="5065776"/>
             <a:ext cx="3355848" cy="256032"/>
           </a:xfrm>
           <a:prstGeom prst="rect">
@@ -4441,7 +4549,9 @@
           <a:noFill/>
         </p:spPr>
         <p:txBody>
-          <a:bodyPr wrap="square" anchor="t"/>
+          <a:bodyPr wrap="square">
+            <a:spAutoFit/>
+          </a:bodyPr>
           <a:lstStyle/>
           <a:p>
             <a:pPr algn="l"/>
@@ -4452,21 +4562,21 @@
                 </a:solidFill>
                 <a:latin typeface="Calibri"/>
               </a:rPr>
-              <a:t>Post-GA (May 22 – Jun 26)</a:t>
-            </a:r>
-          </a:p>
-        </p:txBody>
-      </p:sp>
-      <p:sp>
-        <p:nvSpPr>
-          <p:cNvPr id="32" name="TextBox 31"/>
+              <a:t>Displacement check</a:t>
+            </a:r>
+          </a:p>
+        </p:txBody>
+      </p:sp>
+      <p:sp>
+        <p:nvSpPr>
+          <p:cNvPr id="34" name="TextBox 33"/>
           <p:cNvSpPr txBox="1"/>
           <p:nvPr/>
         </p:nvSpPr>
         <p:spPr>
           <a:xfrm>
-            <a:off x="8284464" y="5404104"/>
-            <a:ext cx="822960" cy="347472"/>
+            <a:off x="8284464" y="5303520"/>
+            <a:ext cx="960120" cy="347472"/>
           </a:xfrm>
           <a:prstGeom prst="rect">
             <a:avLst/>
@@ -4474,7 +4584,9 @@
           <a:noFill/>
         </p:spPr>
         <p:txBody>
-          <a:bodyPr wrap="square" anchor="t"/>
+          <a:bodyPr wrap="square">
+            <a:spAutoFit/>
+          </a:bodyPr>
           <a:lstStyle/>
           <a:p>
             <a:pPr algn="l"/>
@@ -4485,21 +4597,21 @@
                 </a:solidFill>
                 <a:latin typeface="Calibri"/>
               </a:rPr>
-              <a:t>885</a:t>
-            </a:r>
-          </a:p>
-        </p:txBody>
-      </p:sp>
-      <p:sp>
-        <p:nvSpPr>
-          <p:cNvPr id="33" name="TextBox 32"/>
+              <a:t>~6%</a:t>
+            </a:r>
+          </a:p>
+        </p:txBody>
+      </p:sp>
+      <p:sp>
+        <p:nvSpPr>
+          <p:cNvPr id="35" name="TextBox 34"/>
           <p:cNvSpPr txBox="1"/>
           <p:nvPr/>
         </p:nvSpPr>
         <p:spPr>
           <a:xfrm>
-            <a:off x="9098280" y="5513832"/>
-            <a:ext cx="2468880" cy="256032"/>
+            <a:off x="9235440" y="5413248"/>
+            <a:ext cx="2331720" cy="256032"/>
           </a:xfrm>
           <a:prstGeom prst="rect">
             <a:avLst/>
@@ -4507,7 +4619,9 @@
           <a:noFill/>
         </p:spPr>
         <p:txBody>
-          <a:bodyPr wrap="square" anchor="t"/>
+          <a:bodyPr wrap="square">
+            <a:spAutoFit/>
+          </a:bodyPr>
           <a:lstStyle/>
           <a:p>
             <a:pPr algn="l"/>
@@ -4518,21 +4632,21 @@
                 </a:solidFill>
                 <a:latin typeface="Calibri"/>
               </a:rPr>
-              <a:t>peak WAU</a:t>
-            </a:r>
-          </a:p>
-        </p:txBody>
-      </p:sp>
-      <p:sp>
-        <p:nvSpPr>
-          <p:cNvPr id="34" name="TextBox 33"/>
+              <a:t>of report users</a:t>
+            </a:r>
+          </a:p>
+        </p:txBody>
+      </p:sp>
+      <p:sp>
+        <p:nvSpPr>
+          <p:cNvPr id="36" name="TextBox 35"/>
           <p:cNvSpPr txBox="1"/>
           <p:nvPr/>
         </p:nvSpPr>
         <p:spPr>
           <a:xfrm>
-            <a:off x="8284464" y="5824728"/>
-            <a:ext cx="3319272" cy="365760"/>
+            <a:off x="8284464" y="5724144"/>
+            <a:ext cx="3319272" cy="411480"/>
           </a:xfrm>
           <a:prstGeom prst="rect">
             <a:avLst/>
@@ -4540,7 +4654,9 @@
           <a:noFill/>
         </p:spPr>
         <p:txBody>
-          <a:bodyPr wrap="square" anchor="t"/>
+          <a:bodyPr wrap="square">
+            <a:spAutoFit/>
+          </a:bodyPr>
           <a:lstStyle/>
           <a:p>
             <a:pPr algn="l"/>
@@ -4551,7 +4667,7 @@
                 </a:solidFill>
                 <a:latin typeface="Calibri"/>
               </a:rPr>
-              <a:t>Avg 767 · 730–885 across 5 of 6 weeks · Jun 26 dipped to 486.</a:t>
+              <a:t>232 Co-Pilot vs 3,847 report-page users (30d). Opens from calendar/home/inbox — do not pitch “replaces reports” yet.</a:t>
             </a:r>
           </a:p>
         </p:txBody>

</xml_diff>